<commit_message>
fixing mistake in topic name
</commit_message>
<xml_diff>
--- a/Abpanick-Final Presentation.pptx
+++ b/Abpanick-Final Presentation.pptx
@@ -290,6 +290,58 @@
     </p:ext>
   </p:extLst>
 </p:presentation>
+</file>
+
+<file path=ppt/revisionInfo.xml><?xml version="1.0" encoding="utf-8"?>
+<p1510:revInfo xmlns:a="http://schemas.openxmlformats.org/drawingml/2006/main" xmlns:r="http://schemas.openxmlformats.org/officeDocument/2006/relationships" xmlns:p1510="http://schemas.microsoft.com/office/powerpoint/2015/10/main">
+  <p1510:revLst>
+    <p1510:client id="{7394E5B7-3D76-4355-A99B-ED1C5D64A42C}" v="1" dt="2025-09-07T14:15:15.889"/>
+  </p1510:revLst>
+</p1510:revInfo>
+</file>
+
+<file path=ppt/changesInfos/changesInfo1.xml><?xml version="1.0" encoding="utf-8"?>
+<pc:chgInfo xmlns:a="http://schemas.openxmlformats.org/drawingml/2006/main" xmlns:r="http://schemas.openxmlformats.org/officeDocument/2006/relationships" xmlns:ac="http://schemas.microsoft.com/office/drawing/2013/main/command" xmlns:pc="http://schemas.microsoft.com/office/powerpoint/2013/main/command">
+  <pc:docChgLst>
+    <pc:chgData name="Abhilash Panicker" userId="b3697d40-78ff-4571-901a-605f2b67e3c3" providerId="ADAL" clId="{0AA2EE65-2990-4C97-BF95-E8144DB51F9B}"/>
+    <pc:docChg chg="modSld">
+      <pc:chgData name="Abhilash Panicker" userId="b3697d40-78ff-4571-901a-605f2b67e3c3" providerId="ADAL" clId="{0AA2EE65-2990-4C97-BF95-E8144DB51F9B}" dt="2025-09-07T14:15:29.095" v="3" actId="122"/>
+      <pc:docMkLst>
+        <pc:docMk/>
+      </pc:docMkLst>
+      <pc:sldChg chg="modSp mod">
+        <pc:chgData name="Abhilash Panicker" userId="b3697d40-78ff-4571-901a-605f2b67e3c3" providerId="ADAL" clId="{0AA2EE65-2990-4C97-BF95-E8144DB51F9B}" dt="2025-09-07T14:15:29.095" v="3" actId="122"/>
+        <pc:sldMkLst>
+          <pc:docMk/>
+          <pc:sldMk cId="0" sldId="256"/>
+        </pc:sldMkLst>
+        <pc:spChg chg="mod">
+          <ac:chgData name="Abhilash Panicker" userId="b3697d40-78ff-4571-901a-605f2b67e3c3" providerId="ADAL" clId="{0AA2EE65-2990-4C97-BF95-E8144DB51F9B}" dt="2025-09-07T14:15:29.095" v="3" actId="122"/>
+          <ac:spMkLst>
+            <pc:docMk/>
+            <pc:sldMk cId="0" sldId="256"/>
+            <ac:spMk id="86" creationId="{00000000-0000-0000-0000-000000000000}"/>
+          </ac:spMkLst>
+        </pc:spChg>
+      </pc:sldChg>
+      <pc:sldChg chg="modSp mod">
+        <pc:chgData name="Abhilash Panicker" userId="b3697d40-78ff-4571-901a-605f2b67e3c3" providerId="ADAL" clId="{0AA2EE65-2990-4C97-BF95-E8144DB51F9B}" dt="2025-09-07T13:25:03.430" v="0" actId="108"/>
+        <pc:sldMkLst>
+          <pc:docMk/>
+          <pc:sldMk cId="0" sldId="257"/>
+        </pc:sldMkLst>
+        <pc:spChg chg="mod">
+          <ac:chgData name="Abhilash Panicker" userId="b3697d40-78ff-4571-901a-605f2b67e3c3" providerId="ADAL" clId="{0AA2EE65-2990-4C97-BF95-E8144DB51F9B}" dt="2025-09-07T13:25:03.430" v="0" actId="108"/>
+          <ac:spMkLst>
+            <pc:docMk/>
+            <pc:sldMk cId="0" sldId="257"/>
+            <ac:spMk id="93" creationId="{00000000-0000-0000-0000-000000000000}"/>
+          </ac:spMkLst>
+        </pc:spChg>
+      </pc:sldChg>
+    </pc:docChg>
+  </pc:docChgLst>
+</pc:chgInfo>
 </file>
 
 <file path=ppt/notesMasters/notesMaster1.xml><?xml version="1.0" encoding="utf-8"?>
@@ -826,10 +878,10 @@
               <a:buNone/>
             </a:pPr>
             <a:r>
-              <a:rPr lang="en"/>
+              <a:rPr lang="en" dirty="0"/>
               <a:t>Student name - 2 marks</a:t>
             </a:r>
-            <a:endParaRPr/>
+            <a:endParaRPr dirty="0"/>
           </a:p>
           <a:p>
             <a:pPr marL="0" lvl="0" indent="0" algn="l" rtl="0">
@@ -842,10 +894,10 @@
               <a:buNone/>
             </a:pPr>
             <a:r>
-              <a:rPr lang="en"/>
+              <a:rPr lang="en" dirty="0"/>
               <a:t>Mentor’s name - 2 marks</a:t>
             </a:r>
-            <a:endParaRPr/>
+            <a:endParaRPr dirty="0"/>
           </a:p>
           <a:p>
             <a:pPr marL="0" lvl="0" indent="0" algn="l" rtl="0">
@@ -858,10 +910,10 @@
               <a:buNone/>
             </a:pPr>
             <a:r>
-              <a:rPr lang="en"/>
+              <a:rPr lang="en" dirty="0"/>
               <a:t>Topic name - 2 marks </a:t>
             </a:r>
-            <a:endParaRPr/>
+            <a:endParaRPr dirty="0"/>
           </a:p>
           <a:p>
             <a:pPr marL="0" lvl="0" indent="0" algn="l" rtl="0">
@@ -874,10 +926,10 @@
               <a:buNone/>
             </a:pPr>
             <a:r>
-              <a:rPr lang="en"/>
+              <a:rPr lang="en" dirty="0"/>
               <a:t>-&gt; automated grading</a:t>
             </a:r>
-            <a:endParaRPr/>
+            <a:endParaRPr dirty="0"/>
           </a:p>
         </p:txBody>
       </p:sp>
@@ -9055,52 +9107,21 @@
           </a:bodyPr>
           <a:lstStyle/>
           <a:p>
-            <a:pPr marL="0" lvl="0" indent="0" algn="l" rtl="0">
+            <a:pPr lvl="0" algn="ctr">
               <a:lnSpc>
                 <a:spcPct val="218181"/>
               </a:lnSpc>
               <a:spcBef>
                 <a:spcPts val="1200"/>
               </a:spcBef>
-              <a:spcAft>
-                <a:spcPts val="0"/>
-              </a:spcAft>
-              <a:buNone/>
-            </a:pPr>
-            <a:r>
-              <a:rPr lang="en" sz="2300" dirty="0">
-                <a:latin typeface="Times New Roman"/>
-                <a:ea typeface="Times New Roman"/>
-                <a:cs typeface="Times New Roman"/>
-                <a:sym typeface="Times New Roman"/>
-              </a:rPr>
-              <a:t>Data Analytics Capstone Topic</a:t>
-            </a:r>
-            <a:endParaRPr sz="2300" dirty="0">
-              <a:latin typeface="Times New Roman"/>
-              <a:ea typeface="Times New Roman"/>
-              <a:cs typeface="Times New Roman"/>
-              <a:sym typeface="Times New Roman"/>
-            </a:endParaRPr>
-          </a:p>
-          <a:p>
-            <a:pPr marL="0" lvl="0" indent="0" algn="l" rtl="0">
-              <a:lnSpc>
-                <a:spcPct val="218181"/>
-              </a:lnSpc>
-              <a:spcBef>
-                <a:spcPts val="1200"/>
-              </a:spcBef>
-              <a:spcAft>
-                <a:spcPts val="1200"/>
-              </a:spcAft>
-              <a:buClr>
-                <a:schemeClr val="dk1"/>
-              </a:buClr>
-              <a:buSzPts val="1100"/>
-              <a:buFont typeface="Arial"/>
-              <a:buNone/>
-            </a:pPr>
+            </a:pPr>
+            <a:r>
+              <a:rPr lang="en-US" sz="2400" dirty="0"/>
+              <a:t>Monsoon &amp; Macro Signals to Predict Stock Break-Out</a:t>
+            </a:r>
+            <a:br>
+              <a:rPr lang="en-US" sz="2400" dirty="0"/>
+            </a:br>
             <a:r>
               <a:rPr lang="en" sz="2300" dirty="0"/>
               <a:t>Final Presentation</a:t>
@@ -11741,28 +11762,8 @@
               <a:t>Result: </a:t>
             </a:r>
             <a:r>
-              <a:rPr lang="en-GB" b="1" dirty="0"/>
-              <a:t>No model beats naïve baselines</a:t>
-            </a:r>
-            <a:r>
               <a:rPr lang="en-GB" dirty="0"/>
-              <a:t> on this sample. </a:t>
-            </a:r>
-            <a:r>
-              <a:rPr lang="en-GB" b="1" dirty="0"/>
-              <a:t>Recent relative performance</a:t>
-            </a:r>
-            <a:r>
-              <a:rPr lang="en-GB" dirty="0"/>
-              <a:t> (last quarter’s spread) carries the most usable signal. </a:t>
-            </a:r>
-            <a:r>
-              <a:rPr lang="en-GB" b="1" dirty="0"/>
-              <a:t>Macro variables (inflation, GDP, policy rate, monsoon) show weak, unstable lift</a:t>
-            </a:r>
-            <a:r>
-              <a:rPr lang="en-GB" dirty="0"/>
-              <a:t> at a quarterly horizon</a:t>
+              <a:t>No model beats naïve baselines on this sample. Recent relative performance (last quarter’s spread) carries the most usable signal. Macro variables (inflation, GDP, policy rate, monsoon) show weak, unstable lift at a quarterly horizon</a:t>
             </a:r>
             <a:endParaRPr lang="en-US" altLang="en-US" dirty="0"/>
           </a:p>
@@ -15947,4 +15948,10 @@
   <a:objectDefaults/>
   <a:extraClrSchemeLst/>
 </a:theme>
+</file>
+
+<file path=docMetadata/LabelInfo.xml><?xml version="1.0" encoding="utf-8"?>
+<clbl:labelList xmlns:clbl="http://schemas.microsoft.com/office/2020/mipLabelMetadata">
+  <clbl:label id="{87ba5c36-b7cf-4793-bbc2-bd5b3a9f95ca}" enabled="1" method="Privileged" siteId="{72f988bf-86f1-41af-91ab-2d7cd011db47}" removed="0"/>
+</clbl:labelList>
 </file>
</xml_diff>